<commit_message>
feat: refactor into Business Development Due Diligence Hub; single briefing entry for San Sing Screw with ESG and green power analysis
</commit_message>
<xml_diff>
--- a/sansing_consulting_deck.pptx
+++ b/sansing_consulting_deck.pptx
@@ -518,17 +518,17 @@
           </a:p>
           <a:p>
             <a:r>
-              <a:t>① 本頁結論：本簡報全面剖析三星螺絲成型機（朝璟精機）的真實賺錢機制，為前線業務提供精準打擊與談判依據。</a:t>
-            </a:r>
-          </a:p>
-          <a:p>
-            <a:r>
-              <a:t>② 補充說明：本報告透過五大維度交叉查證，杜絕網路拼貼，還原其真實客單價、利潤結構與技術防禦力。</a:t>
-            </a:r>
-          </a:p>
-          <a:p>
-            <a:r>
-              <a:t>③ 下一頁轉場：首先，我們從最關鍵的客單價數據看起，驗證其在市場上的實際價格帶定位。</a:t>
+              <a:t>① 本頁結論：本報告為針對業務開發對象「三星螺絲成型機有限公司（朝璟精機）」之客觀盡職調查，聚焦法人主體、營運體質、財務定價、專利資產、ESG綠電及法律風險。</a:t>
+            </a:r>
+          </a:p>
+          <a:p>
+            <a:r>
+              <a:t>② 補充說明：透過交叉比對公開司法判決、專利公報與產業訪談，排除主觀業務行銷視角，還原其真實營運實態與商務信用等級。</a:t>
+            </a:r>
+          </a:p>
+          <a:p>
+            <a:r>
+              <a:t>③ 下一頁轉場：首先檢視其在資本市場與設備製造領域之核心營運規模與客單價實力。</a:t>
             </a:r>
           </a:p>
         </p:txBody>
@@ -598,22 +598,22 @@
           <a:lstStyle/>
           <a:p>
             <a:r>
-              <a:t>【採用版型與風格】版型 2：並列論法 ｜ Accenture</a:t>
-            </a:r>
-          </a:p>
-          <a:p>
-            <a:r>
-              <a:t>① 本頁結論：前線業務透過拆解隱性成本、主體釐清與驗收保障，能有效瓦解對手低價攻勢。</a:t>
-            </a:r>
-          </a:p>
-          <a:p>
-            <a:r>
-              <a:t>② 補充說明：這些話術全部基於公開判決與客觀事實，能讓業務在客戶面前展現專業的產業內幕洞察。</a:t>
-            </a:r>
-          </a:p>
-          <a:p>
-            <a:r>
-              <a:t>③ 下一頁轉場：除了競爭防禦，若我們是供應鏈廠商，又該如何切入向他們銷售？</a:t>
+              <a:t>【採用版型與風格】版型 6：對立論法 ｜ McKinsey &amp; Company</a:t>
+            </a:r>
+          </a:p>
+          <a:p>
+            <a:r>
+              <a:t>① 本頁結論：其在產品端具備明確的節電賣點，但自身製造端缺乏綠電憑證與 ESG 揭露資產。</a:t>
+            </a:r>
+          </a:p>
+          <a:p>
+            <a:r>
+              <a:t>② 補充說明：扣件廠因應 CBAM 需要買省手機台，這讓三星成型機享有節能紅利；但其自身工廠仍屬傳統型態，未做綠電佈局。</a:t>
+            </a:r>
+          </a:p>
+          <a:p>
+            <a:r>
+              <a:t>③ 下一頁轉場：最後檢視其在司法訴訟與商業契約履行上的歷史風險紀錄。</a:t>
             </a:r>
           </a:p>
         </p:txBody>
@@ -683,22 +683,22 @@
           <a:lstStyle/>
           <a:p>
             <a:r>
-              <a:t>【採用版型與風格】版型 3：結合論法 ｜ McKinsey &amp; Company</a:t>
-            </a:r>
-          </a:p>
-          <a:p>
-            <a:r>
-              <a:t>① 本頁結論：對接這家公司的關鍵在於幫他省下日本零件的昂貴成本，同時分擔他的加工瓶頸。</a:t>
-            </a:r>
-          </a:p>
-          <a:p>
-            <a:r>
-              <a:t>② 補充說明：小於 20 人的機械廠高度依賴外部協力廠，只要能提供品質穩定、價格合理的零組件，切入機會極高。</a:t>
-            </a:r>
-          </a:p>
-          <a:p>
-            <a:r>
-              <a:t>③ 下一頁轉場：最後，我們以麥肯錫金字塔結構總結業務團隊的整體行動綱領。</a:t>
+              <a:t>【採用版型與風格】版型 2：並列論法 ｜ Accenture</a:t>
+            </a:r>
+          </a:p>
+          <a:p>
+            <a:r>
+              <a:t>① 本頁結論：司法判決證明其機台本體質量過關，但配件交付時程曾導致商務摩擦。</a:t>
+            </a:r>
+          </a:p>
+          <a:p>
+            <a:r>
+              <a:t>② 補充說明：法院雖然判決其勝訴（駁回買方解約請求），但凸顯出小廠客製化管理上的人手不足風險。</a:t>
+            </a:r>
+          </a:p>
+          <a:p>
+            <a:r>
+              <a:t>③ 下一頁轉場：綜合上述六大維度，得出本案的盡職調查總結結論與合作建議。</a:t>
             </a:r>
           </a:p>
         </p:txBody>
@@ -773,17 +773,17 @@
           </a:p>
           <a:p>
             <a:r>
-              <a:t>① 本頁結論：本報告不僅提供了競爭對手的全景情資，更為前線業務轉化為具體的攻防行動計畫。</a:t>
-            </a:r>
-          </a:p>
-          <a:p>
-            <a:r>
-              <a:t>② 補充說明：業務團隊應充分利用作戰卡與話術表，在客戶拜訪與供應鏈談判中搶佔主導地位。</a:t>
-            </a:r>
-          </a:p>
-          <a:p>
-            <a:r>
-              <a:t>③ 下一頁轉場：感謝各位，請參閱業務開發知識庫門戶以獲取更多即時動態與下載簡報檔案。</a:t>
+              <a:t>① 本頁結論：整體評估三星螺絲成型機是一家體質精幹的中型專用機製造商，合作具備良好商業價值。</a:t>
+            </a:r>
+          </a:p>
+          <a:p>
+            <a:r>
+              <a:t>② 補充說明：在契約設計上做好驗收細化與能耗合規，即可充分利用其性價比優勢並規避履約爭議。</a:t>
+            </a:r>
+          </a:p>
+          <a:p>
+            <a:r>
+              <a:t>③ 下一頁轉場：感謝各位，完整數據與分析請參見業務開發盡職調查門戶。</a:t>
             </a:r>
           </a:p>
         </p:txBody>
@@ -858,17 +858,17 @@
           </a:p>
           <a:p>
             <a:r>
-              <a:t>① 本頁結論：415 萬元的實際成交價證明該公司並非靠低價傾銷，而是走中階利基路線。</a:t>
-            </a:r>
-          </a:p>
-          <a:p>
-            <a:r>
-              <a:t>② 補充說明：長衝程特殊零件成型機具備技術門檻，使其能維持 400 萬以上的資本財單價。</a:t>
-            </a:r>
-          </a:p>
-          <a:p>
-            <a:r>
-              <a:t>③ 下一頁轉場：能維持此一定價能力，背後依靠的是三個關鍵營運支柱。</a:t>
+              <a:t>① 本頁結論：415 萬元的實際成交價證明該公司具備穩健的資本財溢價能力，並非低價薄利多銷廠。</a:t>
+            </a:r>
+          </a:p>
+          <a:p>
+            <a:r>
+              <a:t>② 補充說明：多沖程特殊長衝程成型機具備技術門檻，使其能維持 400 萬以上的資本財單價。</a:t>
+            </a:r>
+          </a:p>
+          <a:p>
+            <a:r>
+              <a:t>③ 下一頁轉場：進一步檢視支撐此一定價能力的營運架構與供應鏈體質。</a:t>
             </a:r>
           </a:p>
         </p:txBody>
@@ -943,17 +943,17 @@
           </a:p>
           <a:p>
             <a:r>
-              <a:t>① 本頁結論：專利防禦、進口關鍵件混血與極小團隊編制，構成其堅固獲利三角。</a:t>
-            </a:r>
-          </a:p>
-          <a:p>
-            <a:r>
-              <a:t>② 補充說明：這種輕資產、重調校的組裝模式，大幅抵禦了扣件景氣循環的波動風險。</a:t>
-            </a:r>
-          </a:p>
-          <a:p>
-            <a:r>
-              <a:t>③ 下一頁轉場：然而在市場溝通上，前線業務必須先幫客戶釐清一個普遍存在的重大認知誤區。</a:t>
+              <a:t>① 本頁結論：專利防禦、進口關鍵件混血與極小團隊編制，構成其精準生存三角。</a:t>
+            </a:r>
+          </a:p>
+          <a:p>
+            <a:r>
+              <a:t>② 補充說明：這種輕資產、重調校的組裝模式，大幅抵禦了機械業景氣循環的波動風險。</a:t>
+            </a:r>
+          </a:p>
+          <a:p>
+            <a:r>
+              <a:t>③ 下一頁轉場：在法理主體與徵信查核上，必須明確釐清其與上市大廠之界限。</a:t>
             </a:r>
           </a:p>
         </p:txBody>
@@ -1028,17 +1028,17 @@
           </a:p>
           <a:p>
             <a:r>
-              <a:t>① 本頁結論：兩家公司毫無股權與從屬關係，業務必須第一時間矯正客戶的品牌混淆。</a:t>
-            </a:r>
-          </a:p>
-          <a:p>
-            <a:r>
-              <a:t>② 補充說明：三星螺絲成型機是獨立的中小機械廠，不能以千人上市大廠的資源等級來評估其售後與保固。</a:t>
-            </a:r>
-          </a:p>
-          <a:p>
-            <a:r>
-              <a:t>③ 下一頁轉場：釐清身分後，我們進一步拆解其機台買賣的價值鏈與金流留存路徑。</a:t>
+              <a:t>① 本頁結論：兩家公司毫無股權與從屬關係，盡職調查確認其為獨立中小企業。</a:t>
+            </a:r>
+          </a:p>
+          <a:p>
+            <a:r>
+              <a:t>② 補充說明：對外接洽時不得將其與千人上市大廠之資本與售後保證能力混為一談。</a:t>
+            </a:r>
+          </a:p>
+          <a:p>
+            <a:r>
+              <a:t>③ 下一頁轉場：接著檢視其製造與交付流程的端到端價值鏈運作實務。</a:t>
             </a:r>
           </a:p>
         </p:txBody>
@@ -1113,7 +1113,7 @@
           </a:p>
           <a:p>
             <a:r>
-              <a:t>① 本頁結論：其利潤主要鎖在自製調校與專利模組，但交機驗收是其供應鏈管理的最大考驗。</a:t>
+              <a:t>① 本頁結論：其利潤主要鎖在自製調校與專利模組，但交機驗收是其履約管理的最大考驗。</a:t>
             </a:r>
           </a:p>
           <a:p>
@@ -1208,7 +1208,7 @@
           </a:p>
           <a:p>
             <a:r>
-              <a:t>③ 下一頁轉場：在技術本質上，該公司能立足市場的關鍵在於兩項相輔相成的發明與新型專利。</a:t>
+              <a:t>③ 下一頁轉場：在技術資產方面，其核心競爭力建立在兩項相輔相成的專利機構上。</a:t>
             </a:r>
           </a:p>
         </p:txBody>
@@ -1293,7 +1293,7 @@
           </a:p>
           <a:p>
             <a:r>
-              <a:t>③ 下一頁轉場：將此技術力置於全球設備市場中，我們可以看到其鮮明的區隔定位。</a:t>
+              <a:t>③ 下一頁轉場：進一步對照全球市場競爭格局，釐清其所在的市場生態位。</a:t>
             </a:r>
           </a:p>
         </p:txBody>
@@ -1378,7 +1378,7 @@
           </a:p>
           <a:p>
             <a:r>
-              <a:t>③ 下一頁轉場：在策略布局上，其目標客群與產品矩陣展現了明確的 BCG 四象限特徵。</a:t>
+              <a:t>③ 下一頁轉場：在產品組合與市場地理分佈上，展現了鮮明的 BCG 矩陣特徵。</a:t>
             </a:r>
           </a:p>
         </p:txBody>
@@ -1463,7 +1463,7 @@
           </a:p>
           <a:p>
             <a:r>
-              <a:t>③ 下一頁轉場：了解對手的全局態勢後，我們將情報落實為前線業務的具體攻防作戰指引。</a:t>
+              <a:t>③ 下一頁轉場：特別針對現代供應鏈核心的 ESG 與綠電轉型維度進行專題盡職調查。</a:t>
             </a:r>
           </a:p>
         </p:txBody>
@@ -4585,7 +4585,7 @@
               </a:defRPr>
             </a:pPr>
             <a:r>
-              <a:t>4.1.3 業務開發戰情專報  ｜  ZERO-NOISE CONSULTING BRIEFING</a:t>
+              <a:t>4.1.3 業務開發・企業徵信與營運盡職調查報告 (DUE DILIGENCE REPORT)</a:t>
             </a:r>
           </a:p>
         </p:txBody>
@@ -4620,7 +4620,7 @@
               </a:defRPr>
             </a:pPr>
             <a:r>
-              <a:t>三星螺絲成型機有限公司・商業模式解構與業務作戰指引</a:t>
+              <a:t>業務開發對象盡職調查：三星螺絲成型機有限公司（朝璟精機）</a:t>
             </a:r>
           </a:p>
         </p:txBody>
@@ -4655,7 +4655,7 @@
               </a:defRPr>
             </a:pPr>
             <a:r>
-              <a:t>核心主張：避開歐日千萬機台與中國低價紅海，以「極簡20人編制＋日本核心件＋關鍵專利夾具」切入400萬級距特殊零件利基市場</a:t>
+              <a:t>核心主張：避開歐日千萬機台與大陸低價紅海，以「極簡20人編制＋日本核心件＋關鍵專利」立足中階利基，惟面臨 ESG 綠電溯源與交機驗收之履約風險</a:t>
             </a:r>
           </a:p>
         </p:txBody>
@@ -4690,7 +4690,7 @@
               </a:defRPr>
             </a:pPr>
             <a:r>
-              <a:t>研調依據：經濟部商工公示登記・高院判決書 114上149・智財局專利公報・Fastener World 專訪</a:t>
+              <a:t>調查依據：經濟部商工登記・高院 114上149 判決書・智財局專利公報・Fastener World 專訪・歐盟 CBAM 扣件能耗標準</a:t>
             </a:r>
           </a:p>
         </p:txBody>
@@ -4738,12 +4738,12 @@
             <a:pPr>
               <a:defRPr sz="1050" b="1">
                 <a:solidFill>
-                  <a:srgbClr val="A100FF"/>
-                </a:solidFill>
-              </a:defRPr>
-            </a:pPr>
-            <a:r>
-              <a:t>業務作戰話術指南  ｜  版型 2：並列論法  ｜  Accenture Style</a:t>
+                  <a:srgbClr val="D97706"/>
+                </a:solidFill>
+              </a:defRPr>
+            </a:pPr>
+            <a:r>
+              <a:t>ESG 與綠電轉型評估  ｜  版型 6：對立論法  ｜  McKinsey &amp; Company Style</a:t>
             </a:r>
           </a:p>
         </p:txBody>
@@ -4808,12 +4808,12 @@
             <a:pPr>
               <a:defRPr sz="2100" b="1">
                 <a:solidFill>
-                  <a:srgbClr val="111827"/>
-                </a:solidFill>
-              </a:defRPr>
-            </a:pPr>
-            <a:r>
-              <a:t>前線業務對抗指南：拆解三大常見客戶異議與現場反擊金句</a:t>
+                  <a:srgbClr val="051C2C"/>
+                </a:solidFill>
+              </a:defRPr>
+            </a:pPr>
+            <a:r>
+              <a:t>ESG 轉型評估：產品端主打節電 60% 因應 CBAM，惟廠區綠電溯源佈局仍滯後</a:t>
             </a:r>
           </a:p>
           <a:p>
@@ -4825,7 +4825,7 @@
               </a:defRPr>
             </a:pPr>
             <a:r>
-              <a:t>針對客戶比價、主體混淆與交期壓制三大情境，提供行家級反擊論點</a:t>
+              <a:t>針對歐盟 CBAM 碳關稅壓力與綠電 ESG 規範，對比其產品優勢與製造端缺口</a:t>
             </a:r>
           </a:p>
         </p:txBody>
@@ -4845,7 +4845,7 @@
             <a:avLst/>
           </a:prstGeom>
           <a:solidFill>
-            <a:srgbClr val="E2E8F0"/>
+            <a:srgbClr val="CBD5E1"/>
           </a:solidFill>
           <a:ln>
             <a:noFill/>
@@ -4903,32 +4903,30 @@
               </a:defRPr>
             </a:pPr>
             <a:r>
-              <a:t>資料來源：業務實戰對話庫、高分院判決爭議焦點轉化</a:t>
-            </a:r>
-          </a:p>
-        </p:txBody>
-      </p:sp>
-      <p:sp>
-        <p:nvSpPr>
-          <p:cNvPr id="7" name="Rounded Rectangle 6"/>
+              <a:t>資料來源：歐盟 CBAM 扣件申報規範、Fastener World 專訪、經濟部能源署再生能源登記平台</a:t>
+            </a:r>
+          </a:p>
+        </p:txBody>
+      </p:sp>
+      <p:sp>
+        <p:nvSpPr>
+          <p:cNvPr id="7" name="Rectangle 6"/>
           <p:cNvSpPr/>
           <p:nvPr/>
         </p:nvSpPr>
         <p:spPr>
           <a:xfrm>
-            <a:off x="731520" y="1874519"/>
-            <a:ext cx="3393338" cy="4297680"/>
-          </a:xfrm>
-          <a:prstGeom prst="roundRect">
+            <a:off x="2651760" y="1828800"/>
+            <a:ext cx="4297680" cy="502920"/>
+          </a:xfrm>
+          <a:prstGeom prst="rect">
             <a:avLst/>
           </a:prstGeom>
           <a:solidFill>
-            <a:srgbClr val="F9FAFB"/>
+            <a:srgbClr val="051C2C"/>
           </a:solidFill>
-          <a:ln w="12700">
-            <a:solidFill>
-              <a:srgbClr val="E2E8F0"/>
-            </a:solidFill>
+          <a:ln>
+            <a:noFill/>
           </a:ln>
         </p:spPr>
         <p:style>
@@ -4949,7 +4947,16 @@
           <a:bodyPr rtlCol="0" anchor="ctr"/>
           <a:lstStyle/>
           <a:p>
-            <a:pPr algn="ctr"/>
+            <a:pPr algn="ctr">
+              <a:defRPr sz="1400" b="1">
+                <a:solidFill>
+                  <a:srgbClr val="FFFFFF"/>
+                </a:solidFill>
+              </a:defRPr>
+            </a:pPr>
+            <a:r>
+              <a:t>② 見解 A</a:t>
+            </a:r>
           </a:p>
         </p:txBody>
       </p:sp>
@@ -4961,14 +4968,14 @@
         </p:nvSpPr>
         <p:spPr>
           <a:xfrm>
-            <a:off x="731520" y="1874519"/>
-            <a:ext cx="3393338" cy="502920"/>
+            <a:off x="7132320" y="1828800"/>
+            <a:ext cx="4297680" cy="502920"/>
           </a:xfrm>
           <a:prstGeom prst="rect">
             <a:avLst/>
           </a:prstGeom>
           <a:solidFill>
-            <a:srgbClr val="6B21A8"/>
+            <a:srgbClr val="1E3A8A"/>
           </a:solidFill>
           <a:ln>
             <a:noFill/>
@@ -5000,99 +5007,31 @@
               </a:defRPr>
             </a:pPr>
             <a:r>
-              <a:t>情境 1：客戶壓價比價</a:t>
-            </a:r>
-          </a:p>
-        </p:txBody>
-      </p:sp>
-      <p:sp>
-        <p:nvSpPr>
-          <p:cNvPr id="9" name="TextBox 8"/>
-          <p:cNvSpPr txBox="1"/>
-          <p:nvPr/>
-        </p:nvSpPr>
-        <p:spPr>
-          <a:xfrm>
-            <a:off x="914400" y="2514600"/>
-            <a:ext cx="3027578" cy="3520440"/>
-          </a:xfrm>
-          <a:prstGeom prst="rect">
-            <a:avLst/>
-          </a:prstGeom>
-          <a:noFill/>
-        </p:spPr>
-        <p:txBody>
-          <a:bodyPr wrap="square">
-            <a:spAutoFit/>
-          </a:bodyPr>
-          <a:lstStyle/>
-          <a:p>
-            <a:pPr>
-              <a:spcAft>
-                <a:spcPts val="600"/>
-              </a:spcAft>
-              <a:defRPr sz="1250">
-                <a:solidFill>
-                  <a:srgbClr val="0F172A"/>
-                </a:solidFill>
-              </a:defRPr>
-            </a:pPr>
-            <a:r>
-              <a:t>1. 【客戶說法】「三星螺絲成型機才 400 萬，你們怎麼這麼貴？」</a:t>
-            </a:r>
-          </a:p>
-          <a:p>
-            <a:pPr>
-              <a:spcAft>
-                <a:spcPts val="600"/>
-              </a:spcAft>
-              <a:defRPr sz="1250">
-                <a:solidFill>
-                  <a:srgbClr val="0F172A"/>
-                </a:solidFill>
-              </a:defRPr>
-            </a:pPr>
-            <a:r>
-              <a:t>2. 【拆解邏輯】拆解「標準空機」與「專用模組」隱性加價成本</a:t>
-            </a:r>
-          </a:p>
-          <a:p>
-            <a:pPr>
-              <a:spcAft>
-                <a:spcPts val="600"/>
-              </a:spcAft>
-              <a:defRPr sz="1250">
-                <a:solidFill>
-                  <a:srgbClr val="0F172A"/>
-                </a:solidFill>
-              </a:defRPr>
-            </a:pPr>
-            <a:r>
-              <a:t>3. 【反擊金句】「老闆，415 萬是基本款，汽車級長衝程專用翻夾組是外加的。更重要的是妥善率，停機一天損失遠大於機台差價。」</a:t>
-            </a:r>
-          </a:p>
-        </p:txBody>
-      </p:sp>
-      <p:sp>
-        <p:nvSpPr>
-          <p:cNvPr id="10" name="Rounded Rectangle 9"/>
+              <a:t>② 見解 B</a:t>
+            </a:r>
+          </a:p>
+        </p:txBody>
+      </p:sp>
+      <p:sp>
+        <p:nvSpPr>
+          <p:cNvPr id="9" name="Oval 8"/>
           <p:cNvSpPr/>
           <p:nvPr/>
         </p:nvSpPr>
         <p:spPr>
           <a:xfrm>
-            <a:off x="4399178" y="1874519"/>
-            <a:ext cx="3393338" cy="4297680"/>
-          </a:xfrm>
-          <a:prstGeom prst="roundRect">
+            <a:off x="731520" y="2468880"/>
+            <a:ext cx="1737360" cy="868680"/>
+          </a:xfrm>
+          <a:prstGeom prst="ellipse">
             <a:avLst/>
           </a:prstGeom>
           <a:solidFill>
-            <a:srgbClr val="F9FAFB"/>
+            <a:srgbClr val="FEF3C7"/>
           </a:solidFill>
-          <a:ln w="12700">
+          <a:ln>
             <a:solidFill>
-              <a:srgbClr val="E2E8F0"/>
+              <a:srgbClr val="D97706"/>
             </a:solidFill>
           </a:ln>
         </p:spPr>
@@ -5114,29 +5053,37 @@
           <a:bodyPr rtlCol="0" anchor="ctr"/>
           <a:lstStyle/>
           <a:p>
-            <a:pPr algn="ctr"/>
-          </a:p>
-        </p:txBody>
-      </p:sp>
-      <p:sp>
-        <p:nvSpPr>
-          <p:cNvPr id="11" name="Rectangle 10"/>
+            <a:pPr algn="ctr">
+              <a:defRPr sz="1200" b="1">
+                <a:solidFill>
+                  <a:srgbClr val="051C2C"/>
+                </a:solidFill>
+              </a:defRPr>
+            </a:pPr>
+          </a:p>
+        </p:txBody>
+      </p:sp>
+      <p:sp>
+        <p:nvSpPr>
+          <p:cNvPr id="10" name="Rounded Rectangle 9"/>
           <p:cNvSpPr/>
           <p:nvPr/>
         </p:nvSpPr>
         <p:spPr>
           <a:xfrm>
-            <a:off x="4399178" y="1874519"/>
-            <a:ext cx="3393338" cy="502920"/>
-          </a:xfrm>
-          <a:prstGeom prst="rect">
+            <a:off x="2651760" y="2468880"/>
+            <a:ext cx="4297680" cy="868680"/>
+          </a:xfrm>
+          <a:prstGeom prst="roundRect">
             <a:avLst/>
           </a:prstGeom>
           <a:solidFill>
-            <a:srgbClr val="111827"/>
+            <a:srgbClr val="F8FAFC"/>
           </a:solidFill>
           <a:ln>
-            <a:noFill/>
+            <a:solidFill>
+              <a:srgbClr val="CBD5E1"/>
+            </a:solidFill>
           </a:ln>
         </p:spPr>
         <p:style>
@@ -5157,29 +5104,20 @@
           <a:bodyPr rtlCol="0" anchor="ctr"/>
           <a:lstStyle/>
           <a:p>
-            <a:pPr algn="ctr">
-              <a:defRPr sz="1400" b="1">
-                <a:solidFill>
-                  <a:srgbClr val="FFFFFF"/>
-                </a:solidFill>
-              </a:defRPr>
-            </a:pPr>
-            <a:r>
-              <a:t>情境 2：主體混淆澄清</a:t>
-            </a:r>
-          </a:p>
-        </p:txBody>
-      </p:sp>
-      <p:sp>
-        <p:nvSpPr>
-          <p:cNvPr id="12" name="TextBox 11"/>
+            <a:pPr algn="ctr"/>
+          </a:p>
+        </p:txBody>
+      </p:sp>
+      <p:sp>
+        <p:nvSpPr>
+          <p:cNvPr id="11" name="TextBox 10"/>
           <p:cNvSpPr txBox="1"/>
           <p:nvPr/>
         </p:nvSpPr>
         <p:spPr>
           <a:xfrm>
-            <a:off x="4582058" y="2514600"/>
-            <a:ext cx="3027578" cy="3520440"/>
+            <a:off x="2788920" y="2542032"/>
+            <a:ext cx="4023360" cy="722375"/>
           </a:xfrm>
           <a:prstGeom prst="rect">
             <a:avLst/>
@@ -5193,71 +5131,35 @@
           <a:lstStyle/>
           <a:p>
             <a:pPr>
-              <a:spcAft>
-                <a:spcPts val="600"/>
-              </a:spcAft>
-              <a:defRPr sz="1250">
-                <a:solidFill>
-                  <a:srgbClr val="0F172A"/>
-                </a:solidFill>
-              </a:defRPr>
-            </a:pPr>
-            <a:r>
-              <a:t>1. 【客戶說法】「他們是不是上市那個三星螺絲（5007）？」</a:t>
-            </a:r>
-          </a:p>
-          <a:p>
-            <a:pPr>
-              <a:spcAft>
-                <a:spcPts val="600"/>
-              </a:spcAft>
-              <a:defRPr sz="1250">
-                <a:solidFill>
-                  <a:srgbClr val="0F172A"/>
-                </a:solidFill>
-              </a:defRPr>
-            </a:pPr>
-            <a:r>
-              <a:t>2. 【拆解邏輯】破除借光效應，點出實際工廠與編制實況</a:t>
-            </a:r>
-          </a:p>
-          <a:p>
-            <a:pPr>
-              <a:spcAft>
-                <a:spcPts val="600"/>
-              </a:spcAft>
-              <a:defRPr sz="1250">
-                <a:solidFill>
-                  <a:srgbClr val="0F172A"/>
-                </a:solidFill>
-              </a:defRPr>
-            </a:pPr>
-            <a:r>
-              <a:t>3. 【反擊金句】「老闆您誤會了，台南那是螺帽上市龍頭；這家是雲林斗南朝璟體系，全廠不到 20 人，跟上市公司完全無關。」</a:t>
-            </a:r>
-          </a:p>
-        </p:txBody>
-      </p:sp>
-      <p:sp>
-        <p:nvSpPr>
-          <p:cNvPr id="13" name="Rounded Rectangle 12"/>
+              <a:defRPr sz="1200">
+                <a:solidFill>
+                  <a:srgbClr val="1F2937"/>
+                </a:solidFill>
+              </a:defRPr>
+            </a:pPr>
+          </a:p>
+        </p:txBody>
+      </p:sp>
+      <p:sp>
+        <p:nvSpPr>
+          <p:cNvPr id="12" name="Rounded Rectangle 11"/>
           <p:cNvSpPr/>
           <p:nvPr/>
         </p:nvSpPr>
         <p:spPr>
           <a:xfrm>
-            <a:off x="8066836" y="1874519"/>
-            <a:ext cx="3393338" cy="4297680"/>
+            <a:off x="7132320" y="2468880"/>
+            <a:ext cx="4297680" cy="868680"/>
           </a:xfrm>
           <a:prstGeom prst="roundRect">
             <a:avLst/>
           </a:prstGeom>
           <a:solidFill>
-            <a:srgbClr val="F9FAFB"/>
+            <a:srgbClr val="F8FAFC"/>
           </a:solidFill>
-          <a:ln w="12700">
+          <a:ln>
             <a:solidFill>
-              <a:srgbClr val="E2E8F0"/>
+              <a:srgbClr val="CBD5E1"/>
             </a:solidFill>
           </a:ln>
         </p:spPr>
@@ -5285,23 +5187,57 @@
       </p:sp>
       <p:sp>
         <p:nvSpPr>
-          <p:cNvPr id="14" name="Rectangle 13"/>
+          <p:cNvPr id="13" name="TextBox 12"/>
+          <p:cNvSpPr txBox="1"/>
+          <p:nvPr/>
+        </p:nvSpPr>
+        <p:spPr>
+          <a:xfrm>
+            <a:off x="7269480" y="2542032"/>
+            <a:ext cx="4023360" cy="722375"/>
+          </a:xfrm>
+          <a:prstGeom prst="rect">
+            <a:avLst/>
+          </a:prstGeom>
+          <a:noFill/>
+        </p:spPr>
+        <p:txBody>
+          <a:bodyPr wrap="square">
+            <a:spAutoFit/>
+          </a:bodyPr>
+          <a:lstStyle/>
+          <a:p>
+            <a:pPr>
+              <a:defRPr sz="1200">
+                <a:solidFill>
+                  <a:srgbClr val="1F2937"/>
+                </a:solidFill>
+              </a:defRPr>
+            </a:pPr>
+          </a:p>
+        </p:txBody>
+      </p:sp>
+      <p:sp>
+        <p:nvSpPr>
+          <p:cNvPr id="14" name="Oval 13"/>
           <p:cNvSpPr/>
           <p:nvPr/>
         </p:nvSpPr>
         <p:spPr>
           <a:xfrm>
-            <a:off x="8066836" y="1874519"/>
-            <a:ext cx="3393338" cy="502920"/>
-          </a:xfrm>
-          <a:prstGeom prst="rect">
+            <a:off x="731520" y="3447288"/>
+            <a:ext cx="1737360" cy="868680"/>
+          </a:xfrm>
+          <a:prstGeom prst="ellipse">
             <a:avLst/>
           </a:prstGeom>
           <a:solidFill>
-            <a:srgbClr val="6B21A8"/>
+            <a:srgbClr val="FEF3C7"/>
           </a:solidFill>
           <a:ln>
-            <a:noFill/>
+            <a:solidFill>
+              <a:srgbClr val="D97706"/>
+            </a:solidFill>
           </a:ln>
         </p:spPr>
         <p:style>
@@ -5323,28 +5259,70 @@
           <a:lstStyle/>
           <a:p>
             <a:pPr algn="ctr">
-              <a:defRPr sz="1400" b="1">
-                <a:solidFill>
-                  <a:srgbClr val="FFFFFF"/>
-                </a:solidFill>
-              </a:defRPr>
-            </a:pPr>
-            <a:r>
-              <a:t>情境 3：交期壓制化解</a:t>
-            </a:r>
-          </a:p>
-        </p:txBody>
-      </p:sp>
-      <p:sp>
-        <p:nvSpPr>
-          <p:cNvPr id="15" name="TextBox 14"/>
+              <a:defRPr sz="1200" b="1">
+                <a:solidFill>
+                  <a:srgbClr val="051C2C"/>
+                </a:solidFill>
+              </a:defRPr>
+            </a:pPr>
+          </a:p>
+        </p:txBody>
+      </p:sp>
+      <p:sp>
+        <p:nvSpPr>
+          <p:cNvPr id="15" name="Rounded Rectangle 14"/>
+          <p:cNvSpPr/>
+          <p:nvPr/>
+        </p:nvSpPr>
+        <p:spPr>
+          <a:xfrm>
+            <a:off x="2651760" y="3447288"/>
+            <a:ext cx="4297680" cy="868680"/>
+          </a:xfrm>
+          <a:prstGeom prst="roundRect">
+            <a:avLst/>
+          </a:prstGeom>
+          <a:solidFill>
+            <a:srgbClr val="F8FAFC"/>
+          </a:solidFill>
+          <a:ln>
+            <a:solidFill>
+              <a:srgbClr val="CBD5E1"/>
+            </a:solidFill>
+          </a:ln>
+        </p:spPr>
+        <p:style>
+          <a:lnRef idx="1">
+            <a:schemeClr val="accent1"/>
+          </a:lnRef>
+          <a:fillRef idx="3">
+            <a:schemeClr val="accent1"/>
+          </a:fillRef>
+          <a:effectRef idx="2">
+            <a:schemeClr val="accent1"/>
+          </a:effectRef>
+          <a:fontRef idx="minor">
+            <a:schemeClr val="lt1"/>
+          </a:fontRef>
+        </p:style>
+        <p:txBody>
+          <a:bodyPr rtlCol="0" anchor="ctr"/>
+          <a:lstStyle/>
+          <a:p>
+            <a:pPr algn="ctr"/>
+          </a:p>
+        </p:txBody>
+      </p:sp>
+      <p:sp>
+        <p:nvSpPr>
+          <p:cNvPr id="16" name="TextBox 15"/>
           <p:cNvSpPr txBox="1"/>
           <p:nvPr/>
         </p:nvSpPr>
         <p:spPr>
           <a:xfrm>
-            <a:off x="8249716" y="2514600"/>
-            <a:ext cx="3027578" cy="3520440"/>
+            <a:off x="2788920" y="3520440"/>
+            <a:ext cx="4023360" cy="722375"/>
           </a:xfrm>
           <a:prstGeom prst="rect">
             <a:avLst/>
@@ -5358,48 +5336,499 @@
           <a:lstStyle/>
           <a:p>
             <a:pPr>
-              <a:spcAft>
-                <a:spcPts val="600"/>
-              </a:spcAft>
-              <a:defRPr sz="1250">
-                <a:solidFill>
-                  <a:srgbClr val="0F172A"/>
-                </a:solidFill>
-              </a:defRPr>
-            </a:pPr>
-            <a:r>
-              <a:t>1. 【客戶說法】「他們交期很快，兩個月就能裝機出料。」</a:t>
-            </a:r>
-          </a:p>
+              <a:defRPr sz="1200">
+                <a:solidFill>
+                  <a:srgbClr val="1F2937"/>
+                </a:solidFill>
+              </a:defRPr>
+            </a:pPr>
+          </a:p>
+        </p:txBody>
+      </p:sp>
+      <p:sp>
+        <p:nvSpPr>
+          <p:cNvPr id="17" name="Rounded Rectangle 16"/>
+          <p:cNvSpPr/>
+          <p:nvPr/>
+        </p:nvSpPr>
+        <p:spPr>
+          <a:xfrm>
+            <a:off x="7132320" y="3447288"/>
+            <a:ext cx="4297680" cy="868680"/>
+          </a:xfrm>
+          <a:prstGeom prst="roundRect">
+            <a:avLst/>
+          </a:prstGeom>
+          <a:solidFill>
+            <a:srgbClr val="F8FAFC"/>
+          </a:solidFill>
+          <a:ln>
+            <a:solidFill>
+              <a:srgbClr val="CBD5E1"/>
+            </a:solidFill>
+          </a:ln>
+        </p:spPr>
+        <p:style>
+          <a:lnRef idx="1">
+            <a:schemeClr val="accent1"/>
+          </a:lnRef>
+          <a:fillRef idx="3">
+            <a:schemeClr val="accent1"/>
+          </a:fillRef>
+          <a:effectRef idx="2">
+            <a:schemeClr val="accent1"/>
+          </a:effectRef>
+          <a:fontRef idx="minor">
+            <a:schemeClr val="lt1"/>
+          </a:fontRef>
+        </p:style>
+        <p:txBody>
+          <a:bodyPr rtlCol="0" anchor="ctr"/>
+          <a:lstStyle/>
+          <a:p>
+            <a:pPr algn="ctr"/>
+          </a:p>
+        </p:txBody>
+      </p:sp>
+      <p:sp>
+        <p:nvSpPr>
+          <p:cNvPr id="18" name="TextBox 17"/>
+          <p:cNvSpPr txBox="1"/>
+          <p:nvPr/>
+        </p:nvSpPr>
+        <p:spPr>
+          <a:xfrm>
+            <a:off x="7269480" y="3520440"/>
+            <a:ext cx="4023360" cy="722375"/>
+          </a:xfrm>
+          <a:prstGeom prst="rect">
+            <a:avLst/>
+          </a:prstGeom>
+          <a:noFill/>
+        </p:spPr>
+        <p:txBody>
+          <a:bodyPr wrap="square">
+            <a:spAutoFit/>
+          </a:bodyPr>
+          <a:lstStyle/>
           <a:p>
             <a:pPr>
-              <a:spcAft>
-                <a:spcPts val="600"/>
-              </a:spcAft>
-              <a:defRPr sz="1250">
-                <a:solidFill>
-                  <a:srgbClr val="0F172A"/>
-                </a:solidFill>
-              </a:defRPr>
-            </a:pPr>
-            <a:r>
-              <a:t>2. 【拆解邏輯】聚焦「驗收完整度」與「配件到位率」</a:t>
-            </a:r>
-          </a:p>
+              <a:defRPr sz="1200">
+                <a:solidFill>
+                  <a:srgbClr val="1F2937"/>
+                </a:solidFill>
+              </a:defRPr>
+            </a:pPr>
+          </a:p>
+        </p:txBody>
+      </p:sp>
+      <p:sp>
+        <p:nvSpPr>
+          <p:cNvPr id="19" name="Oval 18"/>
+          <p:cNvSpPr/>
+          <p:nvPr/>
+        </p:nvSpPr>
+        <p:spPr>
+          <a:xfrm>
+            <a:off x="731520" y="4425696"/>
+            <a:ext cx="1737360" cy="868680"/>
+          </a:xfrm>
+          <a:prstGeom prst="ellipse">
+            <a:avLst/>
+          </a:prstGeom>
+          <a:solidFill>
+            <a:srgbClr val="FEF3C7"/>
+          </a:solidFill>
+          <a:ln>
+            <a:solidFill>
+              <a:srgbClr val="D97706"/>
+            </a:solidFill>
+          </a:ln>
+        </p:spPr>
+        <p:style>
+          <a:lnRef idx="1">
+            <a:schemeClr val="accent1"/>
+          </a:lnRef>
+          <a:fillRef idx="3">
+            <a:schemeClr val="accent1"/>
+          </a:fillRef>
+          <a:effectRef idx="2">
+            <a:schemeClr val="accent1"/>
+          </a:effectRef>
+          <a:fontRef idx="minor">
+            <a:schemeClr val="lt1"/>
+          </a:fontRef>
+        </p:style>
+        <p:txBody>
+          <a:bodyPr rtlCol="0" anchor="ctr"/>
+          <a:lstStyle/>
+          <a:p>
+            <a:pPr algn="ctr">
+              <a:defRPr sz="1200" b="1">
+                <a:solidFill>
+                  <a:srgbClr val="051C2C"/>
+                </a:solidFill>
+              </a:defRPr>
+            </a:pPr>
+          </a:p>
+        </p:txBody>
+      </p:sp>
+      <p:sp>
+        <p:nvSpPr>
+          <p:cNvPr id="20" name="Rounded Rectangle 19"/>
+          <p:cNvSpPr/>
+          <p:nvPr/>
+        </p:nvSpPr>
+        <p:spPr>
+          <a:xfrm>
+            <a:off x="2651760" y="4425696"/>
+            <a:ext cx="4297680" cy="868680"/>
+          </a:xfrm>
+          <a:prstGeom prst="roundRect">
+            <a:avLst/>
+          </a:prstGeom>
+          <a:solidFill>
+            <a:srgbClr val="F8FAFC"/>
+          </a:solidFill>
+          <a:ln>
+            <a:solidFill>
+              <a:srgbClr val="CBD5E1"/>
+            </a:solidFill>
+          </a:ln>
+        </p:spPr>
+        <p:style>
+          <a:lnRef idx="1">
+            <a:schemeClr val="accent1"/>
+          </a:lnRef>
+          <a:fillRef idx="3">
+            <a:schemeClr val="accent1"/>
+          </a:fillRef>
+          <a:effectRef idx="2">
+            <a:schemeClr val="accent1"/>
+          </a:effectRef>
+          <a:fontRef idx="minor">
+            <a:schemeClr val="lt1"/>
+          </a:fontRef>
+        </p:style>
+        <p:txBody>
+          <a:bodyPr rtlCol="0" anchor="ctr"/>
+          <a:lstStyle/>
+          <a:p>
+            <a:pPr algn="ctr"/>
+          </a:p>
+        </p:txBody>
+      </p:sp>
+      <p:sp>
+        <p:nvSpPr>
+          <p:cNvPr id="21" name="TextBox 20"/>
+          <p:cNvSpPr txBox="1"/>
+          <p:nvPr/>
+        </p:nvSpPr>
+        <p:spPr>
+          <a:xfrm>
+            <a:off x="2788920" y="4498848"/>
+            <a:ext cx="4023360" cy="722375"/>
+          </a:xfrm>
+          <a:prstGeom prst="rect">
+            <a:avLst/>
+          </a:prstGeom>
+          <a:noFill/>
+        </p:spPr>
+        <p:txBody>
+          <a:bodyPr wrap="square">
+            <a:spAutoFit/>
+          </a:bodyPr>
+          <a:lstStyle/>
           <a:p>
             <a:pPr>
-              <a:spcAft>
-                <a:spcPts val="600"/>
-              </a:spcAft>
-              <a:defRPr sz="1250">
-                <a:solidFill>
-                  <a:srgbClr val="0F172A"/>
-                </a:solidFill>
-              </a:defRPr>
-            </a:pPr>
-            <a:r>
-              <a:t>3. 【反擊金句】「快裝機常發生特殊模具配件未齊，最後卡在試車動彈不得。我們合約是全配件到位、打樣達標才結算尾款。」</a:t>
-            </a:r>
+              <a:defRPr sz="1200">
+                <a:solidFill>
+                  <a:srgbClr val="1F2937"/>
+                </a:solidFill>
+              </a:defRPr>
+            </a:pPr>
+          </a:p>
+        </p:txBody>
+      </p:sp>
+      <p:sp>
+        <p:nvSpPr>
+          <p:cNvPr id="22" name="Rounded Rectangle 21"/>
+          <p:cNvSpPr/>
+          <p:nvPr/>
+        </p:nvSpPr>
+        <p:spPr>
+          <a:xfrm>
+            <a:off x="7132320" y="4425696"/>
+            <a:ext cx="4297680" cy="868680"/>
+          </a:xfrm>
+          <a:prstGeom prst="roundRect">
+            <a:avLst/>
+          </a:prstGeom>
+          <a:solidFill>
+            <a:srgbClr val="F8FAFC"/>
+          </a:solidFill>
+          <a:ln>
+            <a:solidFill>
+              <a:srgbClr val="CBD5E1"/>
+            </a:solidFill>
+          </a:ln>
+        </p:spPr>
+        <p:style>
+          <a:lnRef idx="1">
+            <a:schemeClr val="accent1"/>
+          </a:lnRef>
+          <a:fillRef idx="3">
+            <a:schemeClr val="accent1"/>
+          </a:fillRef>
+          <a:effectRef idx="2">
+            <a:schemeClr val="accent1"/>
+          </a:effectRef>
+          <a:fontRef idx="minor">
+            <a:schemeClr val="lt1"/>
+          </a:fontRef>
+        </p:style>
+        <p:txBody>
+          <a:bodyPr rtlCol="0" anchor="ctr"/>
+          <a:lstStyle/>
+          <a:p>
+            <a:pPr algn="ctr"/>
+          </a:p>
+        </p:txBody>
+      </p:sp>
+      <p:sp>
+        <p:nvSpPr>
+          <p:cNvPr id="23" name="TextBox 22"/>
+          <p:cNvSpPr txBox="1"/>
+          <p:nvPr/>
+        </p:nvSpPr>
+        <p:spPr>
+          <a:xfrm>
+            <a:off x="7269480" y="4498848"/>
+            <a:ext cx="4023360" cy="722375"/>
+          </a:xfrm>
+          <a:prstGeom prst="rect">
+            <a:avLst/>
+          </a:prstGeom>
+          <a:noFill/>
+        </p:spPr>
+        <p:txBody>
+          <a:bodyPr wrap="square">
+            <a:spAutoFit/>
+          </a:bodyPr>
+          <a:lstStyle/>
+          <a:p>
+            <a:pPr>
+              <a:defRPr sz="1200">
+                <a:solidFill>
+                  <a:srgbClr val="1F2937"/>
+                </a:solidFill>
+              </a:defRPr>
+            </a:pPr>
+          </a:p>
+        </p:txBody>
+      </p:sp>
+      <p:sp>
+        <p:nvSpPr>
+          <p:cNvPr id="24" name="Oval 23"/>
+          <p:cNvSpPr/>
+          <p:nvPr/>
+        </p:nvSpPr>
+        <p:spPr>
+          <a:xfrm>
+            <a:off x="731520" y="5404104"/>
+            <a:ext cx="1737360" cy="868680"/>
+          </a:xfrm>
+          <a:prstGeom prst="ellipse">
+            <a:avLst/>
+          </a:prstGeom>
+          <a:solidFill>
+            <a:srgbClr val="FEF3C7"/>
+          </a:solidFill>
+          <a:ln>
+            <a:solidFill>
+              <a:srgbClr val="D97706"/>
+            </a:solidFill>
+          </a:ln>
+        </p:spPr>
+        <p:style>
+          <a:lnRef idx="1">
+            <a:schemeClr val="accent1"/>
+          </a:lnRef>
+          <a:fillRef idx="3">
+            <a:schemeClr val="accent1"/>
+          </a:fillRef>
+          <a:effectRef idx="2">
+            <a:schemeClr val="accent1"/>
+          </a:effectRef>
+          <a:fontRef idx="minor">
+            <a:schemeClr val="lt1"/>
+          </a:fontRef>
+        </p:style>
+        <p:txBody>
+          <a:bodyPr rtlCol="0" anchor="ctr"/>
+          <a:lstStyle/>
+          <a:p>
+            <a:pPr algn="ctr">
+              <a:defRPr sz="1200" b="1">
+                <a:solidFill>
+                  <a:srgbClr val="051C2C"/>
+                </a:solidFill>
+              </a:defRPr>
+            </a:pPr>
+          </a:p>
+        </p:txBody>
+      </p:sp>
+      <p:sp>
+        <p:nvSpPr>
+          <p:cNvPr id="25" name="Rounded Rectangle 24"/>
+          <p:cNvSpPr/>
+          <p:nvPr/>
+        </p:nvSpPr>
+        <p:spPr>
+          <a:xfrm>
+            <a:off x="2651760" y="5404104"/>
+            <a:ext cx="4297680" cy="868680"/>
+          </a:xfrm>
+          <a:prstGeom prst="roundRect">
+            <a:avLst/>
+          </a:prstGeom>
+          <a:solidFill>
+            <a:srgbClr val="F8FAFC"/>
+          </a:solidFill>
+          <a:ln>
+            <a:solidFill>
+              <a:srgbClr val="CBD5E1"/>
+            </a:solidFill>
+          </a:ln>
+        </p:spPr>
+        <p:style>
+          <a:lnRef idx="1">
+            <a:schemeClr val="accent1"/>
+          </a:lnRef>
+          <a:fillRef idx="3">
+            <a:schemeClr val="accent1"/>
+          </a:fillRef>
+          <a:effectRef idx="2">
+            <a:schemeClr val="accent1"/>
+          </a:effectRef>
+          <a:fontRef idx="minor">
+            <a:schemeClr val="lt1"/>
+          </a:fontRef>
+        </p:style>
+        <p:txBody>
+          <a:bodyPr rtlCol="0" anchor="ctr"/>
+          <a:lstStyle/>
+          <a:p>
+            <a:pPr algn="ctr"/>
+          </a:p>
+        </p:txBody>
+      </p:sp>
+      <p:sp>
+        <p:nvSpPr>
+          <p:cNvPr id="26" name="TextBox 25"/>
+          <p:cNvSpPr txBox="1"/>
+          <p:nvPr/>
+        </p:nvSpPr>
+        <p:spPr>
+          <a:xfrm>
+            <a:off x="2788920" y="5477256"/>
+            <a:ext cx="4023360" cy="722375"/>
+          </a:xfrm>
+          <a:prstGeom prst="rect">
+            <a:avLst/>
+          </a:prstGeom>
+          <a:noFill/>
+        </p:spPr>
+        <p:txBody>
+          <a:bodyPr wrap="square">
+            <a:spAutoFit/>
+          </a:bodyPr>
+          <a:lstStyle/>
+          <a:p>
+            <a:pPr>
+              <a:defRPr sz="1200">
+                <a:solidFill>
+                  <a:srgbClr val="1F2937"/>
+                </a:solidFill>
+              </a:defRPr>
+            </a:pPr>
+          </a:p>
+        </p:txBody>
+      </p:sp>
+      <p:sp>
+        <p:nvSpPr>
+          <p:cNvPr id="27" name="Rounded Rectangle 26"/>
+          <p:cNvSpPr/>
+          <p:nvPr/>
+        </p:nvSpPr>
+        <p:spPr>
+          <a:xfrm>
+            <a:off x="7132320" y="5404104"/>
+            <a:ext cx="4297680" cy="868680"/>
+          </a:xfrm>
+          <a:prstGeom prst="roundRect">
+            <a:avLst/>
+          </a:prstGeom>
+          <a:solidFill>
+            <a:srgbClr val="F8FAFC"/>
+          </a:solidFill>
+          <a:ln>
+            <a:solidFill>
+              <a:srgbClr val="CBD5E1"/>
+            </a:solidFill>
+          </a:ln>
+        </p:spPr>
+        <p:style>
+          <a:lnRef idx="1">
+            <a:schemeClr val="accent1"/>
+          </a:lnRef>
+          <a:fillRef idx="3">
+            <a:schemeClr val="accent1"/>
+          </a:fillRef>
+          <a:effectRef idx="2">
+            <a:schemeClr val="accent1"/>
+          </a:effectRef>
+          <a:fontRef idx="minor">
+            <a:schemeClr val="lt1"/>
+          </a:fontRef>
+        </p:style>
+        <p:txBody>
+          <a:bodyPr rtlCol="0" anchor="ctr"/>
+          <a:lstStyle/>
+          <a:p>
+            <a:pPr algn="ctr"/>
+          </a:p>
+        </p:txBody>
+      </p:sp>
+      <p:sp>
+        <p:nvSpPr>
+          <p:cNvPr id="28" name="TextBox 27"/>
+          <p:cNvSpPr txBox="1"/>
+          <p:nvPr/>
+        </p:nvSpPr>
+        <p:spPr>
+          <a:xfrm>
+            <a:off x="7269480" y="5477256"/>
+            <a:ext cx="4023360" cy="722375"/>
+          </a:xfrm>
+          <a:prstGeom prst="rect">
+            <a:avLst/>
+          </a:prstGeom>
+          <a:noFill/>
+        </p:spPr>
+        <p:txBody>
+          <a:bodyPr wrap="square">
+            <a:spAutoFit/>
+          </a:bodyPr>
+          <a:lstStyle/>
+          <a:p>
+            <a:pPr>
+              <a:defRPr sz="1200">
+                <a:solidFill>
+                  <a:srgbClr val="1F2937"/>
+                </a:solidFill>
+              </a:defRPr>
+            </a:pPr>
           </a:p>
         </p:txBody>
       </p:sp>
@@ -5446,12 +5875,12 @@
             <a:pPr>
               <a:defRPr sz="1050" b="1">
                 <a:solidFill>
-                  <a:srgbClr val="D97706"/>
-                </a:solidFill>
-              </a:defRPr>
-            </a:pPr>
-            <a:r>
-              <a:t>供應鏈攻堅策略  ｜  版型 3：結合論法  ｜  McKinsey &amp; Company Style</a:t>
+                  <a:srgbClr val="A100FF"/>
+                </a:solidFill>
+              </a:defRPr>
+            </a:pPr>
+            <a:r>
+              <a:t>司法履約風險查核  ｜  版型 2：並列論法  ｜  Accenture Style</a:t>
             </a:r>
           </a:p>
         </p:txBody>
@@ -5516,12 +5945,12 @@
             <a:pPr>
               <a:defRPr sz="2100" b="1">
                 <a:solidFill>
-                  <a:srgbClr val="051C2C"/>
-                </a:solidFill>
-              </a:defRPr>
-            </a:pPr>
-            <a:r>
-              <a:t>若向其推銷供應鏈產品：以「日本件平替」與「熱處理加工能量」為雙突破口</a:t>
+                  <a:srgbClr val="111827"/>
+                </a:solidFill>
+              </a:defRPr>
+            </a:pPr>
+            <a:r>
+              <a:t>司法裁判風險覆核：履約合約爭議集中於「配件隨機交付」與「驗收標準」</a:t>
             </a:r>
           </a:p>
           <a:p>
@@ -5533,7 +5962,7 @@
               </a:defRPr>
             </a:pPr>
             <a:r>
-              <a:t>切中其小於20人、重外包組裝之營運模式，以高精度高性價比供應鏈對接採購</a:t>
+              <a:t>以高院 114上149 實案剖析商務履約盲點與合作合約防範要項</a:t>
             </a:r>
           </a:p>
         </p:txBody>
@@ -5553,7 +5982,7 @@
             <a:avLst/>
           </a:prstGeom>
           <a:solidFill>
-            <a:srgbClr val="CBD5E1"/>
+            <a:srgbClr val="E2E8F0"/>
           </a:solidFill>
           <a:ln>
             <a:noFill/>
@@ -5611,7 +6040,7 @@
               </a:defRPr>
             </a:pPr>
             <a:r>
-              <a:t>資料來源：機械製造業 B2B 供應鏈攻堅模型、朝璟精機外包協作體系分析</a:t>
+              <a:t>資料來源：臺灣高等法院臺南分院 114年度上字第149號民事判決書全文</a:t>
             </a:r>
           </a:p>
         </p:txBody>
@@ -5624,17 +6053,19 @@
         </p:nvSpPr>
         <p:spPr>
           <a:xfrm>
-            <a:off x="2011680" y="1783080"/>
-            <a:ext cx="8138160" cy="731520"/>
+            <a:off x="731520" y="1874519"/>
+            <a:ext cx="3393338" cy="4297680"/>
           </a:xfrm>
           <a:prstGeom prst="roundRect">
             <a:avLst/>
           </a:prstGeom>
           <a:solidFill>
-            <a:srgbClr val="051C2C"/>
+            <a:srgbClr val="F9FAFB"/>
           </a:solidFill>
-          <a:ln>
-            <a:noFill/>
+          <a:ln w="12700">
+            <a:solidFill>
+              <a:srgbClr val="E2E8F0"/>
+            </a:solidFill>
           </a:ln>
         </p:spPr>
         <p:style>
@@ -5655,35 +6086,26 @@
           <a:bodyPr rtlCol="0" anchor="ctr"/>
           <a:lstStyle/>
           <a:p>
-            <a:pPr algn="ctr">
-              <a:defRPr sz="1400" b="1">
-                <a:solidFill>
-                  <a:srgbClr val="FFFFFF"/>
-                </a:solidFill>
-              </a:defRPr>
-            </a:pPr>
-            <a:r>
-              <a:t>掌握斗南廠依賴外包之結構特性，以「降低採購成本」與「紓解產能瓶頸」為提案主軸</a:t>
-            </a:r>
-          </a:p>
-        </p:txBody>
-      </p:sp>
-      <p:sp>
-        <p:nvSpPr>
-          <p:cNvPr id="8" name="Rounded Rectangle 7"/>
+            <a:pPr algn="ctr"/>
+          </a:p>
+        </p:txBody>
+      </p:sp>
+      <p:sp>
+        <p:nvSpPr>
+          <p:cNvPr id="8" name="Rectangle 7"/>
           <p:cNvSpPr/>
           <p:nvPr/>
         </p:nvSpPr>
         <p:spPr>
           <a:xfrm>
-            <a:off x="731520" y="2788920"/>
-            <a:ext cx="5193792" cy="777240"/>
-          </a:xfrm>
-          <a:prstGeom prst="roundRect">
+            <a:off x="731520" y="1874519"/>
+            <a:ext cx="3393338" cy="502920"/>
+          </a:xfrm>
+          <a:prstGeom prst="rect">
             <a:avLst/>
           </a:prstGeom>
           <a:solidFill>
-            <a:srgbClr val="1E3A8A"/>
+            <a:srgbClr val="6B21A8"/>
           </a:solidFill>
           <a:ln>
             <a:noFill/>
@@ -5708,38 +6130,106 @@
           <a:lstStyle/>
           <a:p>
             <a:pPr algn="ctr">
-              <a:defRPr sz="1350" b="1">
+              <a:defRPr sz="1400" b="1">
                 <a:solidFill>
                   <a:srgbClr val="FFFFFF"/>
                 </a:solidFill>
               </a:defRPr>
             </a:pPr>
             <a:r>
-              <a:t>突破口 1：日本進口件成本優化方案（平替軸承與合金鋼）</a:t>
-            </a:r>
-          </a:p>
-        </p:txBody>
-      </p:sp>
-      <p:sp>
-        <p:nvSpPr>
-          <p:cNvPr id="9" name="Rounded Rectangle 8"/>
+              <a:t>判決爭議焦點（實案）</a:t>
+            </a:r>
+          </a:p>
+        </p:txBody>
+      </p:sp>
+      <p:sp>
+        <p:nvSpPr>
+          <p:cNvPr id="9" name="TextBox 8"/>
+          <p:cNvSpPr txBox="1"/>
+          <p:nvPr/>
+        </p:nvSpPr>
+        <p:spPr>
+          <a:xfrm>
+            <a:off x="914400" y="2514600"/>
+            <a:ext cx="3027578" cy="3520440"/>
+          </a:xfrm>
+          <a:prstGeom prst="rect">
+            <a:avLst/>
+          </a:prstGeom>
+          <a:noFill/>
+        </p:spPr>
+        <p:txBody>
+          <a:bodyPr wrap="square">
+            <a:spAutoFit/>
+          </a:bodyPr>
+          <a:lstStyle/>
+          <a:p>
+            <a:pPr>
+              <a:spcAft>
+                <a:spcPts val="600"/>
+              </a:spcAft>
+              <a:defRPr sz="1250">
+                <a:solidFill>
+                  <a:srgbClr val="0F172A"/>
+                </a:solidFill>
+              </a:defRPr>
+            </a:pPr>
+            <a:r>
+              <a:t>1. 買方（鉅準有限公司）主張購買 PF86L 機台包含「會翻會夾組」等三零件</a:t>
+            </a:r>
+          </a:p>
+          <a:p>
+            <a:pPr>
+              <a:spcAft>
+                <a:spcPts val="600"/>
+              </a:spcAft>
+              <a:defRPr sz="1250">
+                <a:solidFill>
+                  <a:srgbClr val="0F172A"/>
+                </a:solidFill>
+              </a:defRPr>
+            </a:pPr>
+            <a:r>
+              <a:t>2. 主機雖送達買方處所，但特定夾具配件延誤交付引發買賣信任破裂</a:t>
+            </a:r>
+          </a:p>
+          <a:p>
+            <a:pPr>
+              <a:spcAft>
+                <a:spcPts val="600"/>
+              </a:spcAft>
+              <a:defRPr sz="1250">
+                <a:solidFill>
+                  <a:srgbClr val="0F172A"/>
+                </a:solidFill>
+              </a:defRPr>
+            </a:pPr>
+            <a:r>
+              <a:t>3. 買方訴請解除契約並請求返還 415 萬價金，法院最終駁回買方請求</a:t>
+            </a:r>
+          </a:p>
+        </p:txBody>
+      </p:sp>
+      <p:sp>
+        <p:nvSpPr>
+          <p:cNvPr id="10" name="Rounded Rectangle 9"/>
           <p:cNvSpPr/>
           <p:nvPr/>
         </p:nvSpPr>
         <p:spPr>
           <a:xfrm>
-            <a:off x="731520" y="3840480"/>
-            <a:ext cx="1639824" cy="2286000"/>
+            <a:off x="4399178" y="1874519"/>
+            <a:ext cx="3393338" cy="4297680"/>
           </a:xfrm>
           <a:prstGeom prst="roundRect">
             <a:avLst/>
           </a:prstGeom>
           <a:solidFill>
-            <a:srgbClr val="F8FAFC"/>
+            <a:srgbClr val="F9FAFB"/>
           </a:solidFill>
-          <a:ln w="15240">
+          <a:ln w="12700">
             <a:solidFill>
-              <a:srgbClr val="D97706"/>
+              <a:srgbClr val="E2E8F0"/>
             </a:solidFill>
           </a:ln>
         </p:spPr>
@@ -5767,60 +6257,23 @@
       </p:sp>
       <p:sp>
         <p:nvSpPr>
-          <p:cNvPr id="10" name="TextBox 9"/>
-          <p:cNvSpPr txBox="1"/>
-          <p:nvPr/>
-        </p:nvSpPr>
-        <p:spPr>
-          <a:xfrm>
-            <a:off x="822960" y="3931920"/>
-            <a:ext cx="1456944" cy="2103120"/>
-          </a:xfrm>
-          <a:prstGeom prst="rect">
-            <a:avLst/>
-          </a:prstGeom>
-          <a:noFill/>
-        </p:spPr>
-        <p:txBody>
-          <a:bodyPr wrap="square">
-            <a:spAutoFit/>
-          </a:bodyPr>
-          <a:lstStyle/>
-          <a:p>
-            <a:pPr>
-              <a:defRPr sz="1150">
-                <a:solidFill>
-                  <a:srgbClr val="1F2937"/>
-                </a:solidFill>
-              </a:defRPr>
-            </a:pPr>
-            <a:r>
-              <a:t>鎖定其每台必備之高精密滾柱軸承，提供等規台德認證平替件，可降低其 15% 採購成本</a:t>
-            </a:r>
-          </a:p>
-        </p:txBody>
-      </p:sp>
-      <p:sp>
-        <p:nvSpPr>
-          <p:cNvPr id="11" name="Rounded Rectangle 10"/>
+          <p:cNvPr id="11" name="Rectangle 10"/>
           <p:cNvSpPr/>
           <p:nvPr/>
         </p:nvSpPr>
         <p:spPr>
           <a:xfrm>
-            <a:off x="2508504" y="3840480"/>
-            <a:ext cx="1639824" cy="2286000"/>
-          </a:xfrm>
-          <a:prstGeom prst="roundRect">
+            <a:off x="4399178" y="1874519"/>
+            <a:ext cx="3393338" cy="502920"/>
+          </a:xfrm>
+          <a:prstGeom prst="rect">
             <a:avLst/>
           </a:prstGeom>
           <a:solidFill>
-            <a:srgbClr val="F8FAFC"/>
+            <a:srgbClr val="111827"/>
           </a:solidFill>
-          <a:ln w="15240">
-            <a:solidFill>
-              <a:srgbClr val="D97706"/>
-            </a:solidFill>
+          <a:ln>
+            <a:noFill/>
           </a:ln>
         </p:spPr>
         <p:style>
@@ -5841,7 +6294,16 @@
           <a:bodyPr rtlCol="0" anchor="ctr"/>
           <a:lstStyle/>
           <a:p>
-            <a:pPr algn="ctr"/>
+            <a:pPr algn="ctr">
+              <a:defRPr sz="1400" b="1">
+                <a:solidFill>
+                  <a:srgbClr val="FFFFFF"/>
+                </a:solidFill>
+              </a:defRPr>
+            </a:pPr>
+            <a:r>
+              <a:t>法院判決法律理由</a:t>
+            </a:r>
           </a:p>
         </p:txBody>
       </p:sp>
@@ -5853,8 +6315,8 @@
         </p:nvSpPr>
         <p:spPr>
           <a:xfrm>
-            <a:off x="2599944" y="3931920"/>
-            <a:ext cx="1456944" cy="2103120"/>
+            <a:off x="4582058" y="2514600"/>
+            <a:ext cx="3027578" cy="3520440"/>
           </a:xfrm>
           <a:prstGeom prst="rect">
             <a:avLst/>
@@ -5868,14 +6330,47 @@
           <a:lstStyle/>
           <a:p>
             <a:pPr>
-              <a:defRPr sz="1150">
-                <a:solidFill>
-                  <a:srgbClr val="1F2937"/>
-                </a:solidFill>
-              </a:defRPr>
-            </a:pPr>
-            <a:r>
-              <a:t>提供特殊耐磨模具合金鋼與客製切斷裁切服務，縮短其備料等待期</a:t>
+              <a:spcAft>
+                <a:spcPts val="600"/>
+              </a:spcAft>
+              <a:defRPr sz="1250">
+                <a:solidFill>
+                  <a:srgbClr val="0F172A"/>
+                </a:solidFill>
+              </a:defRPr>
+            </a:pPr>
+            <a:r>
+              <a:t>1. 法院認定主機已交付且可運作，未交付配件屬附隨義務或可分之零件</a:t>
+            </a:r>
+          </a:p>
+          <a:p>
+            <a:pPr>
+              <a:spcAft>
+                <a:spcPts val="600"/>
+              </a:spcAft>
+              <a:defRPr sz="1250">
+                <a:solidFill>
+                  <a:srgbClr val="0F172A"/>
+                </a:solidFill>
+              </a:defRPr>
+            </a:pPr>
+            <a:r>
+              <a:t>2. 買方不得因少數配件缺漏而全面主張解除全機契約並要求退還全部價金</a:t>
+            </a:r>
+          </a:p>
+          <a:p>
+            <a:pPr>
+              <a:spcAft>
+                <a:spcPts val="600"/>
+              </a:spcAft>
+              <a:defRPr sz="1250">
+                <a:solidFill>
+                  <a:srgbClr val="0F172A"/>
+                </a:solidFill>
+              </a:defRPr>
+            </a:pPr>
+            <a:r>
+              <a:t>3. 三星/朝璟在主機本體質量上獲得司法認定，但凸顯出配件交付管理疏失</a:t>
             </a:r>
           </a:p>
         </p:txBody>
@@ -5888,18 +6383,18 @@
         </p:nvSpPr>
         <p:spPr>
           <a:xfrm>
-            <a:off x="4285488" y="3840480"/>
-            <a:ext cx="1639824" cy="2286000"/>
+            <a:off x="8066836" y="1874519"/>
+            <a:ext cx="3393338" cy="4297680"/>
           </a:xfrm>
           <a:prstGeom prst="roundRect">
             <a:avLst/>
           </a:prstGeom>
           <a:solidFill>
-            <a:srgbClr val="F8FAFC"/>
+            <a:srgbClr val="F9FAFB"/>
           </a:solidFill>
-          <a:ln w="15240">
+          <a:ln w="12700">
             <a:solidFill>
-              <a:srgbClr val="D97706"/>
+              <a:srgbClr val="E2E8F0"/>
             </a:solidFill>
           </a:ln>
         </p:spPr>
@@ -5927,55 +6422,20 @@
       </p:sp>
       <p:sp>
         <p:nvSpPr>
-          <p:cNvPr id="14" name="TextBox 13"/>
-          <p:cNvSpPr txBox="1"/>
-          <p:nvPr/>
-        </p:nvSpPr>
-        <p:spPr>
-          <a:xfrm>
-            <a:off x="4376928" y="3931920"/>
-            <a:ext cx="1456944" cy="2103120"/>
-          </a:xfrm>
-          <a:prstGeom prst="rect">
-            <a:avLst/>
-          </a:prstGeom>
-          <a:noFill/>
-        </p:spPr>
-        <p:txBody>
-          <a:bodyPr wrap="square">
-            <a:spAutoFit/>
-          </a:bodyPr>
-          <a:lstStyle/>
-          <a:p>
-            <a:pPr>
-              <a:defRPr sz="1150">
-                <a:solidFill>
-                  <a:srgbClr val="1F2937"/>
-                </a:solidFill>
-              </a:defRPr>
-            </a:pPr>
-            <a:r>
-              <a:t>提供寄銷（VMI）庫存管理模式，協助其緩解小廠營運資金壓力</a:t>
-            </a:r>
-          </a:p>
-        </p:txBody>
-      </p:sp>
-      <p:sp>
-        <p:nvSpPr>
-          <p:cNvPr id="15" name="Rounded Rectangle 14"/>
+          <p:cNvPr id="14" name="Rectangle 13"/>
           <p:cNvSpPr/>
           <p:nvPr/>
         </p:nvSpPr>
         <p:spPr>
           <a:xfrm>
-            <a:off x="6263640" y="2788920"/>
-            <a:ext cx="5193792" cy="777240"/>
-          </a:xfrm>
-          <a:prstGeom prst="roundRect">
+            <a:off x="8066836" y="1874519"/>
+            <a:ext cx="3393338" cy="502920"/>
+          </a:xfrm>
+          <a:prstGeom prst="rect">
             <a:avLst/>
           </a:prstGeom>
           <a:solidFill>
-            <a:srgbClr val="1E3A8A"/>
+            <a:srgbClr val="6B21A8"/>
           </a:solidFill>
           <a:ln>
             <a:noFill/>
@@ -6000,73 +6460,28 @@
           <a:lstStyle/>
           <a:p>
             <a:pPr algn="ctr">
-              <a:defRPr sz="1350" b="1">
+              <a:defRPr sz="1400" b="1">
                 <a:solidFill>
                   <a:srgbClr val="FFFFFF"/>
                 </a:solidFill>
               </a:defRPr>
             </a:pPr>
             <a:r>
-              <a:t>突破口 2：高精密導軌加工與高週波熱處理能量</a:t>
-            </a:r>
-          </a:p>
-        </p:txBody>
-      </p:sp>
-      <p:sp>
-        <p:nvSpPr>
-          <p:cNvPr id="16" name="Rounded Rectangle 15"/>
-          <p:cNvSpPr/>
-          <p:nvPr/>
-        </p:nvSpPr>
-        <p:spPr>
-          <a:xfrm>
-            <a:off x="6263640" y="3840480"/>
-            <a:ext cx="1639824" cy="2286000"/>
-          </a:xfrm>
-          <a:prstGeom prst="roundRect">
-            <a:avLst/>
-          </a:prstGeom>
-          <a:solidFill>
-            <a:srgbClr val="F8FAFC"/>
-          </a:solidFill>
-          <a:ln w="15240">
-            <a:solidFill>
-              <a:srgbClr val="CBD5E1"/>
-            </a:solidFill>
-          </a:ln>
-        </p:spPr>
-        <p:style>
-          <a:lnRef idx="1">
-            <a:schemeClr val="accent1"/>
-          </a:lnRef>
-          <a:fillRef idx="3">
-            <a:schemeClr val="accent1"/>
-          </a:fillRef>
-          <a:effectRef idx="2">
-            <a:schemeClr val="accent1"/>
-          </a:effectRef>
-          <a:fontRef idx="minor">
-            <a:schemeClr val="lt1"/>
-          </a:fontRef>
-        </p:style>
-        <p:txBody>
-          <a:bodyPr rtlCol="0" anchor="ctr"/>
-          <a:lstStyle/>
-          <a:p>
-            <a:pPr algn="ctr"/>
-          </a:p>
-        </p:txBody>
-      </p:sp>
-      <p:sp>
-        <p:nvSpPr>
-          <p:cNvPr id="17" name="TextBox 16"/>
+              <a:t>盡職調查風控建議</a:t>
+            </a:r>
+          </a:p>
+        </p:txBody>
+      </p:sp>
+      <p:sp>
+        <p:nvSpPr>
+          <p:cNvPr id="15" name="TextBox 14"/>
           <p:cNvSpPr txBox="1"/>
           <p:nvPr/>
         </p:nvSpPr>
         <p:spPr>
           <a:xfrm>
-            <a:off x="6355079" y="3931920"/>
-            <a:ext cx="1456944" cy="2103120"/>
+            <a:off x="8249716" y="2514600"/>
+            <a:ext cx="3027578" cy="3520440"/>
           </a:xfrm>
           <a:prstGeom prst="rect">
             <a:avLst/>
@@ -6080,174 +6495,47 @@
           <a:lstStyle/>
           <a:p>
             <a:pPr>
-              <a:defRPr sz="1150">
-                <a:solidFill>
-                  <a:srgbClr val="1F2937"/>
-                </a:solidFill>
-              </a:defRPr>
-            </a:pPr>
-            <a:r>
-              <a:t>提供大型機身龍門銑削外協產能，解決斗南廠自製機加工產能不足瓶頸</a:t>
-            </a:r>
-          </a:p>
-        </p:txBody>
-      </p:sp>
-      <p:sp>
-        <p:nvSpPr>
-          <p:cNvPr id="18" name="Rounded Rectangle 17"/>
-          <p:cNvSpPr/>
-          <p:nvPr/>
-        </p:nvSpPr>
-        <p:spPr>
-          <a:xfrm>
-            <a:off x="8040624" y="3840480"/>
-            <a:ext cx="1639824" cy="2286000"/>
-          </a:xfrm>
-          <a:prstGeom prst="roundRect">
-            <a:avLst/>
-          </a:prstGeom>
-          <a:solidFill>
-            <a:srgbClr val="F8FAFC"/>
-          </a:solidFill>
-          <a:ln w="15240">
-            <a:solidFill>
-              <a:srgbClr val="CBD5E1"/>
-            </a:solidFill>
-          </a:ln>
-        </p:spPr>
-        <p:style>
-          <a:lnRef idx="1">
-            <a:schemeClr val="accent1"/>
-          </a:lnRef>
-          <a:fillRef idx="3">
-            <a:schemeClr val="accent1"/>
-          </a:fillRef>
-          <a:effectRef idx="2">
-            <a:schemeClr val="accent1"/>
-          </a:effectRef>
-          <a:fontRef idx="minor">
-            <a:schemeClr val="lt1"/>
-          </a:fontRef>
-        </p:style>
-        <p:txBody>
-          <a:bodyPr rtlCol="0" anchor="ctr"/>
-          <a:lstStyle/>
-          <a:p>
-            <a:pPr algn="ctr"/>
-          </a:p>
-        </p:txBody>
-      </p:sp>
-      <p:sp>
-        <p:nvSpPr>
-          <p:cNvPr id="19" name="TextBox 18"/>
-          <p:cNvSpPr txBox="1"/>
-          <p:nvPr/>
-        </p:nvSpPr>
-        <p:spPr>
-          <a:xfrm>
-            <a:off x="8132063" y="3931920"/>
-            <a:ext cx="1456944" cy="2103120"/>
-          </a:xfrm>
-          <a:prstGeom prst="rect">
-            <a:avLst/>
-          </a:prstGeom>
-          <a:noFill/>
-        </p:spPr>
-        <p:txBody>
-          <a:bodyPr wrap="square">
-            <a:spAutoFit/>
-          </a:bodyPr>
-          <a:lstStyle/>
+              <a:spcAft>
+                <a:spcPts val="600"/>
+              </a:spcAft>
+              <a:defRPr sz="1250">
+                <a:solidFill>
+                  <a:srgbClr val="0F172A"/>
+                </a:solidFill>
+              </a:defRPr>
+            </a:pPr>
+            <a:r>
+              <a:t>1. 合作合約必須明確訂立「主機與客製專用配件之雙軌獨立驗收清單」</a:t>
+            </a:r>
+          </a:p>
           <a:p>
             <a:pPr>
-              <a:defRPr sz="1150">
-                <a:solidFill>
-                  <a:srgbClr val="1F2937"/>
-                </a:solidFill>
-              </a:defRPr>
-            </a:pPr>
-            <a:r>
-              <a:t>協助建立關鍵曲軸與滑塊熱處理金相檢驗報告，提升其整機外銷歐美認證資格</a:t>
-            </a:r>
-          </a:p>
-        </p:txBody>
-      </p:sp>
-      <p:sp>
-        <p:nvSpPr>
-          <p:cNvPr id="20" name="Rounded Rectangle 19"/>
-          <p:cNvSpPr/>
-          <p:nvPr/>
-        </p:nvSpPr>
-        <p:spPr>
-          <a:xfrm>
-            <a:off x="9817608" y="3840480"/>
-            <a:ext cx="1639824" cy="2286000"/>
-          </a:xfrm>
-          <a:prstGeom prst="roundRect">
-            <a:avLst/>
-          </a:prstGeom>
-          <a:solidFill>
-            <a:srgbClr val="F8FAFC"/>
-          </a:solidFill>
-          <a:ln w="15240">
-            <a:solidFill>
-              <a:srgbClr val="CBD5E1"/>
-            </a:solidFill>
-          </a:ln>
-        </p:spPr>
-        <p:style>
-          <a:lnRef idx="1">
-            <a:schemeClr val="accent1"/>
-          </a:lnRef>
-          <a:fillRef idx="3">
-            <a:schemeClr val="accent1"/>
-          </a:fillRef>
-          <a:effectRef idx="2">
-            <a:schemeClr val="accent1"/>
-          </a:effectRef>
-          <a:fontRef idx="minor">
-            <a:schemeClr val="lt1"/>
-          </a:fontRef>
-        </p:style>
-        <p:txBody>
-          <a:bodyPr rtlCol="0" anchor="ctr"/>
-          <a:lstStyle/>
-          <a:p>
-            <a:pPr algn="ctr"/>
-          </a:p>
-        </p:txBody>
-      </p:sp>
-      <p:sp>
-        <p:nvSpPr>
-          <p:cNvPr id="21" name="TextBox 20"/>
-          <p:cNvSpPr txBox="1"/>
-          <p:nvPr/>
-        </p:nvSpPr>
-        <p:spPr>
-          <a:xfrm>
-            <a:off x="9909048" y="3931920"/>
-            <a:ext cx="1456944" cy="2103120"/>
-          </a:xfrm>
-          <a:prstGeom prst="rect">
-            <a:avLst/>
-          </a:prstGeom>
-          <a:noFill/>
-        </p:spPr>
-        <p:txBody>
-          <a:bodyPr wrap="square">
-            <a:spAutoFit/>
-          </a:bodyPr>
-          <a:lstStyle/>
+              <a:spcAft>
+                <a:spcPts val="600"/>
+              </a:spcAft>
+              <a:defRPr sz="1250">
+                <a:solidFill>
+                  <a:srgbClr val="0F172A"/>
+                </a:solidFill>
+              </a:defRPr>
+            </a:pPr>
+            <a:r>
+              <a:t>2. 約定以客觀樣品衝壓良率（如連續衝壓 1,000 顆無公差超標）為尾款前提</a:t>
+            </a:r>
+          </a:p>
           <a:p>
             <a:pPr>
-              <a:defRPr sz="1150">
-                <a:solidFill>
-                  <a:srgbClr val="1F2937"/>
-                </a:solidFill>
-              </a:defRPr>
-            </a:pPr>
-            <a:r>
-              <a:t>以在地快速交期與穩定品管，成為其外包體系中的一級戰略合作夥伴</a:t>
+              <a:spcAft>
+                <a:spcPts val="600"/>
+              </a:spcAft>
+              <a:defRPr sz="1250">
+                <a:solidFill>
+                  <a:srgbClr val="0F172A"/>
+                </a:solidFill>
+              </a:defRPr>
+            </a:pPr>
+            <a:r>
+              <a:t>3. 要求提供完整的備品清單與 48 小時內到廠叫修服務水平承諾（SLA）</a:t>
             </a:r>
           </a:p>
         </p:txBody>
@@ -6300,7 +6588,7 @@
               </a:defRPr>
             </a:pPr>
             <a:r>
-              <a:t>總結行動綱領  ｜  版型 3：結合論法  ｜  McKinsey &amp; Company Style</a:t>
+              <a:t>盡職調查綜合結論  ｜  版型 3：結合論法  ｜  McKinsey &amp; Company Style</a:t>
             </a:r>
           </a:p>
         </p:txBody>
@@ -6370,7 +6658,7 @@
               </a:defRPr>
             </a:pPr>
             <a:r>
-              <a:t>業務團隊行動綱領：落實「主體認知、合約嚴謹、供應鏈穿透」三大戰役</a:t>
+              <a:t>盡職調查綜合結論：商業營運信用評為「中上（B+）」，合作須落實雙向避險</a:t>
             </a:r>
           </a:p>
           <a:p>
@@ -6382,7 +6670,7 @@
               </a:defRPr>
             </a:pPr>
             <a:r>
-              <a:t>轉化情資為實質業績，於市場競爭、客戶開發與供應鏈對接中取得全面主動</a:t>
+              <a:t>整合法人主體、財務體質、專利壁壘、ESG 綠電合規與合約風控之總結建言</a:t>
             </a:r>
           </a:p>
         </p:txBody>
@@ -6460,7 +6748,7 @@
               </a:defRPr>
             </a:pPr>
             <a:r>
-              <a:t>資料來源：4.1.3 業務開發策略白皮書 ｜ 業務戰情知識庫門戶專報</a:t>
+              <a:t>資料來源：4.1.3 業務開發盡職調查白皮書 ｜ 企業徵信與營運評估專報</a:t>
             </a:r>
           </a:p>
         </p:txBody>
@@ -6512,7 +6800,7 @@
               </a:defRPr>
             </a:pPr>
             <a:r>
-              <a:t>情資變現三步走：破除品牌迷思、建立 TCO 比價工具、對接斗南廠外包鏈</a:t>
+              <a:t>商務可行性良好且技術具利基，惟須落實交機驗收標準化與能耗數據約定</a:t>
             </a:r>
           </a:p>
         </p:txBody>
@@ -6564,7 +6852,7 @@
               </a:defRPr>
             </a:pPr>
             <a:r>
-              <a:t>戰線 A：客戶端——建立 5 年 TCO 總持有成本試算模型</a:t>
+              <a:t>正面支撐要素（合作可行性：良好）</a:t>
             </a:r>
           </a:p>
         </p:txBody>
@@ -6644,7 +6932,7 @@
               </a:defRPr>
             </a:pPr>
             <a:r>
-              <a:t>拜訪螺絲廠時主動出示「全配件驗收實質合約」，凸顯我方驗收合規保障</a:t>
+              <a:t>財務體質精簡：全廠 &lt;20 人，固定負擔輕，無重資產負債暴雷風險</a:t>
             </a:r>
           </a:p>
         </p:txBody>
@@ -6724,7 +7012,7 @@
               </a:defRPr>
             </a:pPr>
             <a:r>
-              <a:t>以停機一天損失（約 5~10 萬元）對照原廠售後團隊規模，凸顯我方服務能量</a:t>
+              <a:t>利基市場定價權：單台 415 萬合約定價證明產品具備真實商業變現價值</a:t>
             </a:r>
           </a:p>
         </p:txBody>
@@ -6804,7 +7092,7 @@
               </a:defRPr>
             </a:pPr>
             <a:r>
-              <a:t>協助客戶精算 5 年電費、模具損耗與維修費用，瓦解對手初始購機價格優勢</a:t>
+              <a:t>核心技術護城河：發明與新型雙專利佈局，且具備產品端 60% 節能之 CBAM 紅利</a:t>
             </a:r>
           </a:p>
         </p:txBody>
@@ -6856,7 +7144,7 @@
               </a:defRPr>
             </a:pPr>
             <a:r>
-              <a:t>戰線 B：供應鏈端——直接對接斗南廠關鍵決策者（廖冠傑／廖彥榮）</a:t>
+              <a:t>風控配套要素（避險要求：嚴格）</a:t>
             </a:r>
           </a:p>
         </p:txBody>
@@ -6936,7 +7224,7 @@
               </a:defRPr>
             </a:pPr>
             <a:r>
-              <a:t>針對進口軸承與特殊鋼材提出樣品測試與成本節省對照方案</a:t>
+              <a:t>合約主機與配件分拆驗收：避免因客製模具延遲引發全案付款停滯糾紛</a:t>
             </a:r>
           </a:p>
         </p:txBody>
@@ -7016,7 +7304,7 @@
               </a:defRPr>
             </a:pPr>
             <a:r>
-              <a:t>建立專屬技術對接窗口，主動參與其新一代節能抗震成型機之先期研發</a:t>
+              <a:t>ESG 能耗與綠電條款：約定機台交付時須附出廠能耗實測報告以符合客戶稽核</a:t>
             </a:r>
           </a:p>
         </p:txBody>
@@ -7096,7 +7384,7 @@
               </a:defRPr>
             </a:pPr>
             <a:r>
-              <a:t>將本份調研納入業務知識庫，持續追蹤其海外參展與專利更新動態</a:t>
+              <a:t>售後服務水平保障：針對小團隊售後瓶頸，簽約時須明確載明維修響應時限</a:t>
             </a:r>
           </a:p>
         </p:txBody>
@@ -7149,7 +7437,7 @@
               </a:defRPr>
             </a:pPr>
             <a:r>
-              <a:t>市場定價定位  ｜  版型 1：一對一論法  ｜  BCG (Boston Consulting Group) Style</a:t>
+              <a:t>資本與定價核實  ｜  版型 1：一對一論法  ｜  BCG (Boston Consulting Group) Style</a:t>
             </a:r>
           </a:p>
         </p:txBody>
@@ -7219,7 +7507,7 @@
               </a:defRPr>
             </a:pPr>
             <a:r>
-              <a:t>415 萬單台均價錨定中階利基，驗證其避開低價競爭的客單價實力</a:t>
+              <a:t>415 萬單台均價錨定中階利基，具備中等資本財之合約議價與獲利能力</a:t>
             </a:r>
           </a:p>
           <a:p>
@@ -7231,7 +7519,7 @@
               </a:defRPr>
             </a:pPr>
             <a:r>
-              <a:t>以司法判決真實合約價比對兩岸及歐日冷鍛成型機價格帶分布</a:t>
+              <a:t>以司法判決真實成交合約比對兩岸及歐日冷鍛成型機價格帶分布</a:t>
             </a:r>
           </a:p>
         </p:txBody>
@@ -8002,7 +8290,7 @@
               </a:defRPr>
             </a:pPr>
             <a:r>
-              <a:t>• 價格精準卡在「中小型螺絲廠買得起、大陸廉價機做不出」的最佳甜蜜點。</a:t>
+              <a:t>• 定價證明其非走低價傾銷路線，而是卡位「中小型扣件廠買得起、大陸機做不出」之利基帶。</a:t>
             </a:r>
           </a:p>
         </p:txBody>
@@ -8055,7 +8343,7 @@
               </a:defRPr>
             </a:pPr>
             <a:r>
-              <a:t>核心競爭優勢  ｜  版型 2：並列論法  ｜  Accenture Style</a:t>
+              <a:t>營運體質評估  ｜  版型 2：並列論法  ｜  Accenture Style</a:t>
             </a:r>
           </a:p>
         </p:txBody>
@@ -8125,7 +8413,7 @@
               </a:defRPr>
             </a:pPr>
             <a:r>
-              <a:t>三大營運支柱共構防禦力：專利機構、日本關鍵件與小於20人精兵管銷</a:t>
+              <a:t>營運體質三大支柱：核心專利防禦、日台零組件混血與小於20人精兵架構</a:t>
             </a:r>
           </a:p>
           <a:p>
@@ -8137,7 +8425,7 @@
               </a:defRPr>
             </a:pPr>
             <a:r>
-              <a:t>從研發、供應鏈到人事管理維度歸納其高生存率與高利潤留存之原因</a:t>
+              <a:t>從研發、供應鏈到人事管理維度評估其營運持續性與財務抗風險能力</a:t>
             </a:r>
           </a:p>
         </p:txBody>
@@ -8763,7 +9051,7 @@
               </a:defRPr>
             </a:pPr>
             <a:r>
-              <a:t>企業主體辨識  ｜  版型 6：對立論法  ｜  McKinsey &amp; Company Style</a:t>
+              <a:t>法人主體徵信  ｜  版型 6：對立論法  ｜  McKinsey &amp; Company Style</a:t>
             </a:r>
           </a:p>
         </p:txBody>
@@ -8833,7 +9121,7 @@
               </a:defRPr>
             </a:pPr>
             <a:r>
-              <a:t>釐清市場混淆：非台南上市扣件龍頭，實為雲林斗南獨立專用機製造商</a:t>
+              <a:t>法人主體與股權徵信：獨立製造商，與台南上市公司「三星科技 5007」無關</a:t>
             </a:r>
           </a:p>
           <a:p>
@@ -8845,7 +9133,7 @@
               </a:defRPr>
             </a:pPr>
             <a:r>
-              <a:t>上市大廠「三星科技 5007」與「三星螺絲成型機」之跨維度事實比對</a:t>
+              <a:t>比對上市公司「三星科技 5007」與「三星螺絲成型機」，釐清法律責任與實力邊界</a:t>
             </a:r>
           </a:p>
         </p:txBody>
@@ -9900,7 +10188,7 @@
               </a:defRPr>
             </a:pPr>
             <a:r>
-              <a:t>端到端價值鏈診斷  ｜  版型 5：麥肯錫論法  ｜  McKinsey &amp; Company Style</a:t>
+              <a:t>價值鏈運作診斷  ｜  版型 5：麥肯錫論法  ｜  McKinsey &amp; Company Style</a:t>
             </a:r>
           </a:p>
         </p:txBody>
@@ -9970,7 +10258,7 @@
               </a:defRPr>
             </a:pPr>
             <a:r>
-              <a:t>端到端價值鏈診斷：高毛利源於關鍵組裝與模組選配，最大風險在交機驗收</a:t>
+              <a:t>端到端價值鏈運作診斷：高毛利源於關鍵組裝，履約最大盲點在配件驗收</a:t>
             </a:r>
           </a:p>
           <a:p>
@@ -11215,7 +11503,7 @@
               </a:defRPr>
             </a:pPr>
             <a:r>
-              <a:t>資本財交易四階段閉環：自訂金支付至最終驗收的完整金流鏈條</a:t>
+              <a:t>商業金流因果閉環：採資本財專案付款機制，到廠驗收前鎖定現金流</a:t>
             </a:r>
           </a:p>
           <a:p>
@@ -12070,7 +12358,7 @@
               </a:defRPr>
             </a:pPr>
             <a:r>
-              <a:t>專利技術護城河  ｜  版型 3：結合論法  ｜  BCG (Boston Consulting Group) Style</a:t>
+              <a:t>技術資產評估  ｜  版型 3：結合論法  ｜  BCG (Boston Consulting Group) Style</a:t>
             </a:r>
           </a:p>
         </p:txBody>
@@ -12140,7 +12428,7 @@
               </a:defRPr>
             </a:pPr>
             <a:r>
-              <a:t>「翻轉夾持」與「作動抑震」兩大專利同時成立，方能切入汽機車特殊長件</a:t>
+              <a:t>「翻轉夾持」與「作動抑震」兩大專利協同，構成特殊長件技術壁壘</a:t>
             </a:r>
           </a:p>
           <a:p>
@@ -12919,7 +13207,7 @@
               </a:defRPr>
             </a:pPr>
             <a:r>
-              <a:t>產業生態位比較  ｜  版型 7：比較論法  ｜  BCG (Boston Consulting Group) Style</a:t>
+              <a:t>產業生態位分析  ｜  版型 7：比較論法  ｜  BCG (Boston Consulting Group) Style</a:t>
             </a:r>
           </a:p>
         </p:txBody>
@@ -12989,7 +13277,7 @@
               </a:defRPr>
             </a:pPr>
             <a:r>
-              <a:t>跨國設備三梯隊定位：兼具台灣靈活性與日本耐久度，專攻預算中堅市場</a:t>
+              <a:t>設備三梯隊生態位定位：以歐日機 1/3 價格提供 85% 性能的平替方案</a:t>
             </a:r>
           </a:p>
           <a:p>
@@ -13546,7 +13834,7 @@
               </a:defRPr>
             </a:pPr>
             <a:r>
-              <a:t>產品與市場矩陣  ｜  版型 8：BCG 矩陣  ｜  BCG (Boston Consulting Group) Style</a:t>
+              <a:t>市場與產品組合  ｜  版型 8：BCG 矩陣  ｜  BCG (Boston Consulting Group) Style</a:t>
             </a:r>
           </a:p>
         </p:txBody>
@@ -13616,7 +13904,7 @@
               </a:defRPr>
             </a:pPr>
             <a:r>
-              <a:t>以「客群市場 × 設備複雜度」拆解其策略重心：外銷長衝程為主要現金增長點</a:t>
+              <a:t>市場客戶組合分析：新興國外銷特殊機為核心動能，國內標準機趨於成熟</a:t>
             </a:r>
           </a:p>
           <a:p>

</xml_diff>